<commit_message>
Slides update and energy meter calibration
</commit_message>
<xml_diff>
--- a/slides/ECRL_2LAL_Progress_Review.pptx
+++ b/slides/ECRL_2LAL_Progress_Review.pptx
@@ -1442,7 +1442,7 @@
           <a:lstStyle/>
           <a:p>
             <a:r>
-              <a:t>Contrast the two width families explicitly. In ECRL sizing up helps at high frequency. In 2LAL it hurts everywhere we measured. Those are different design rules for two families that superficially do the same job.</a:t>
+              <a:t>This is the 8-stage ring deck. An earlier version of this slide showed a minimum near 100 MHz and a 'leakage floor' below it; both came from the open-chain deck, whose last node was never restored. In both families width helps at high frequency; only 2LAL shows a width optimum at the slow end.</a:t>
             </a:r>
           </a:p>
         </p:txBody>
@@ -1722,7 +1722,7 @@
           <a:lstStyle/>
           <a:p>
             <a:r>
-              <a:t>Resist the temptation to declare a winner. The honest finding is that under matched conditions these two families are much closer than the literature's enthusiasm suggests, and which one wins depends entirely on where you sit on the frequency axis.</a:t>
+              <a:t>An earlier version of this slide reported a tie at 100 MHz and an ECRL win at low frequency. Both came from the open-chain 2LAL deck, whose last node was never restored; closing it into a ring removed them. The ordering now matches what quasi- versus fully-adiabatic theory predicts.</a:t>
             </a:r>
           </a:p>
         </p:txBody>
@@ -2002,7 +2002,7 @@
           <a:lstStyle/>
           <a:p>
             <a:r>
-              <a:t>Lead with the first one if asked what is most important. The inverter comparison is close to a tie; real logic is where the topologies diverge, because a 2LAL gate does logic in the pass network while ECRL does it in the pull-down tree.</a:t>
+              <a:t>Lead with the first one if asked what is most important. On the inverter 2LAL wins on energy everywhere; real logic is where the topologies diverge, because a 2LAL gate does logic in the pass network while ECRL does it in the pull-down tree.</a:t>
             </a:r>
           </a:p>
         </p:txBody>
@@ -2492,7 +2492,7 @@
           <a:lstStyle/>
           <a:p>
             <a:r>
-              <a:t>Be explicit about this before showing any graph. A reviewer who assumes f_clock when we plot f_tr will think our crossover is at 25 MHz when it is at 100 MHz on our axis. Both versions of every plot are in the repo.</a:t>
+              <a:t>Be explicit about this before showing any graph. A reviewer who assumes f_clock when we plot f_tr will misread every frequency on our axes by a factor of four. Both versions of every plot are in the repo.</a:t>
             </a:r>
           </a:p>
         </p:txBody>
@@ -12785,7 +12785,7 @@
                 </a:solidFill>
                 <a:latin typeface="Calibri"/>
               </a:rPr>
-              <a:t>The upturn below ~50 MHz is real. </a:t>
+              <a:t>The upturn below ~50 MHz is not leakage. </a:t>
             </a:r>
             <a:r>
               <a:rPr sz="1350" b="0" i="0">
@@ -12794,7 +12794,7 @@
                 </a:solidFill>
                 <a:latin typeface="Calibri"/>
               </a:rPr>
-              <a:t>That is the leakage floor, not a broken circuit — the logic is still correct there.</a:t>
+              <a:t>This is the superseded open-chain deck; its unrestored last node inflates slow-clock energy. Slide 20 uses the ring.</a:t>
             </a:r>
           </a:p>
         </p:txBody>
@@ -13075,7 +13075,7 @@
                 </a:solidFill>
                 <a:latin typeface="Calibri"/>
               </a:rPr>
-              <a:t>A minimum, not a monotone</a:t>
+              <a:t>Falls all the way down</a:t>
             </a:r>
           </a:p>
           <a:p>
@@ -13094,7 +13094,7 @@
                 </a:solidFill>
                 <a:latin typeface="Calibri"/>
               </a:rPr>
-              <a:t>Unlike ECRL, the 2LAL curve turns up at both ends. The minimum sits near f_tr = 100 MHz.</a:t>
+              <a:t>No floor in this range: 46.1 fJ at f_tr = 1000 MHz down to 0.93 fJ at 10 MHz (W = 1.0 µm), about 7× per decade.</a:t>
             </a:r>
           </a:p>
           <a:p>
@@ -13106,7 +13106,7 @@
                 <a:spcPts val="1100"/>
               </a:spcBef>
               <a:buClr>
-                <a:srgbClr val="A4237A"/>
+                <a:srgbClr val="12866B"/>
               </a:buClr>
               <a:buFont typeface="Arial"/>
               <a:buChar char="▪"/>
@@ -13118,7 +13118,7 @@
                 </a:solidFill>
                 <a:latin typeface="Calibri"/>
               </a:rPr>
-              <a:t>Above it: </a:t>
+              <a:t>That is the fully adiabatic signature: </a:t>
             </a:r>
             <a:r>
               <a:rPr sz="1350" b="0" i="0">
@@ -13127,7 +13127,7 @@
                 </a:solidFill>
                 <a:latin typeface="Calibri"/>
               </a:rPr>
-              <a:t>the same resistive RC/T loss ECRL has.</a:t>
+              <a:t>only the resistive RC/T loss, with no threshold residue of the kind ECRL keeps.</a:t>
             </a:r>
           </a:p>
           <a:p>
@@ -13151,7 +13151,7 @@
                 </a:solidFill>
                 <a:latin typeface="Calibri"/>
               </a:rPr>
-              <a:t>Below it: </a:t>
+              <a:t>Wider is better down to 50 MHz. </a:t>
             </a:r>
             <a:r>
               <a:rPr sz="1350" b="0" i="0">
@@ -13160,7 +13160,7 @@
                 </a:solidFill>
                 <a:latin typeface="Calibri"/>
               </a:rPr>
-              <a:t>a leakage floor. 16 transistors per column hold charge for progressively longer, which costs more the slower you run. Confirmed as leakage, not a malfunction: the logic is still correct at 10 MHz.</a:t>
+              <a:t>At 1000 MHz, W = 3.0 µm costs 33% less than W = 0.84 µm (33.9 against 50.3 fJ): the pass gates are resistance-limited.</a:t>
             </a:r>
           </a:p>
           <a:p>
@@ -13184,7 +13184,7 @@
                 </a:solidFill>
                 <a:latin typeface="Calibri"/>
               </a:rPr>
-              <a:t>Wider is worse here, at every frequency. </a:t>
+              <a:t>At 10 MHz the widest devices turn back up. </a:t>
             </a:r>
             <a:r>
               <a:rPr sz="1350" b="0" i="0">
@@ -13193,7 +13193,7 @@
                 </a:solidFill>
                 <a:latin typeface="Calibri"/>
               </a:rPr>
-              <a:t>The opposite of ECRL. These pass gates are not resistance-limited here, so width buys nothing and costs capacitance and leakage.</a:t>
+              <a:t>W = 1.5 µm is lowest (0.62 fJ), W = 3.0 µm costs 0.90 fJ, consistent with leakage that grows with width.</a:t>
             </a:r>
           </a:p>
           <a:p>
@@ -13212,7 +13212,7 @@
                 </a:solidFill>
                 <a:latin typeface="Calibri"/>
               </a:rPr>
-              <a:t>That single difference in the sizing trend is, on its own, a useful design result: in 2LAL, do not upsize.</a:t>
+              <a:t>Design result: in 2LAL, size up for speed, but stop near 1.5 µm for slow clocks.</a:t>
             </a:r>
           </a:p>
         </p:txBody>
@@ -15331,7 +15331,7 @@
                           </a:solidFill>
                           <a:latin typeface="Calibri"/>
                         </a:rPr>
-                        <a:t>rail energy over one T_rail = 4·Tp</a:t>
+                        <a:t>rail energy over four T_rail = 16·Tp</a:t>
                       </a:r>
                     </a:p>
                   </a:txBody>
@@ -15354,7 +15354,7 @@
                           </a:solidFill>
                           <a:latin typeface="Calibri"/>
                         </a:rPr>
-                        <a:t>4 metered columns</a:t>
+                        <a:t>8 ring columns × 4 periods</a:t>
                       </a:r>
                     </a:p>
                   </a:txBody>
@@ -16030,6 +16030,39 @@
                 <a:spcPts val="1100"/>
               </a:spcBef>
               <a:buClr>
+                <a:srgbClr val="12866B"/>
+              </a:buClr>
+              <a:buFont typeface="Arial"/>
+              <a:buChar char="▪"/>
+            </a:pPr>
+            <a:r>
+              <a:rPr sz="1350" b="1" i="0">
+                <a:solidFill>
+                  <a:srgbClr val="12866B"/>
+                </a:solidFill>
+                <a:latin typeface="Calibri"/>
+              </a:rPr>
+              <a:t>2LAL is lower at every frequency. </a:t>
+            </a:r>
+            <a:r>
+              <a:rPr sz="1350" b="0" i="0">
+                <a:solidFill>
+                  <a:srgbClr val="3D4756"/>
+                </a:solidFill>
+                <a:latin typeface="Calibri"/>
+              </a:rPr>
+              <a:t>From 1.19× at 1000 MHz to 13.4× at 10 MHz. At 100 MHz: 21.66 fJ against 6.29 fJ.</a:t>
+            </a:r>
+          </a:p>
+          <a:p>
+            <a:pPr algn="l" marL="237744" indent="-237744">
+              <a:lnSpc>
+                <a:spcPct val="114000"/>
+              </a:lnSpc>
+              <a:spcBef>
+                <a:spcPts val="1000"/>
+              </a:spcBef>
+              <a:buClr>
                 <a:srgbClr val="768295"/>
               </a:buClr>
               <a:buFont typeface="Arial"/>
@@ -16042,7 +16075,7 @@
                 </a:solidFill>
                 <a:latin typeface="Calibri"/>
               </a:rPr>
-              <a:t>They tie at f_tr = 100 MHz. </a:t>
+              <a:t>The gap widens as the clock slows. </a:t>
             </a:r>
             <a:r>
               <a:rPr sz="1350" b="0" i="0">
@@ -16051,40 +16084,7 @@
                 </a:solidFill>
                 <a:latin typeface="Calibri"/>
               </a:rPr>
-              <a:t>21.66 fJ against 21.62 fJ. Not a coincidence — both are doing the same physical work, one 25 fF node charged and discharged adiabatically per operation.</a:t>
-            </a:r>
-          </a:p>
-          <a:p>
-            <a:pPr algn="l" marL="237744" indent="-237744">
-              <a:lnSpc>
-                <a:spcPct val="114000"/>
-              </a:lnSpc>
-              <a:spcBef>
-                <a:spcPts val="1000"/>
-              </a:spcBef>
-              <a:buClr>
-                <a:srgbClr val="12866B"/>
-              </a:buClr>
-              <a:buFont typeface="Arial"/>
-              <a:buChar char="▪"/>
-            </a:pPr>
-            <a:r>
-              <a:rPr sz="1350" b="1" i="0">
-                <a:solidFill>
-                  <a:srgbClr val="12866B"/>
-                </a:solidFill>
-                <a:latin typeface="Calibri"/>
-              </a:rPr>
-              <a:t>2LAL's advantage band is narrow and modest. </a:t>
-            </a:r>
-            <a:r>
-              <a:rPr sz="1350" b="0" i="0">
-                <a:solidFill>
-                  <a:srgbClr val="3D4756"/>
-                </a:solidFill>
-                <a:latin typeface="Calibri"/>
-              </a:rPr>
-              <a:t>f_tr 200–500 MHz, and only by 7–13%.</a:t>
+              <a:t>ECRL keeps a threshold residue, C·|Vtp|²/2, that speed does not remove; 2LAL keeps falling with T_phase.</a:t>
             </a:r>
           </a:p>
           <a:p>
@@ -16108,7 +16108,7 @@
                 </a:solidFill>
                 <a:latin typeface="Calibri"/>
               </a:rPr>
-              <a:t>ECRL wins clearly at low frequency. </a:t>
+              <a:t>2LAL pays in transistors, not energy. </a:t>
             </a:r>
             <a:r>
               <a:rPr sz="1350" b="0" i="0">
@@ -16117,7 +16117,7 @@
                 </a:solidFill>
                 <a:latin typeface="Calibri"/>
               </a:rPr>
-              <a:t>3.5× better at 10 MHz, because 2LAL's leakage floor — 16 transistors per column against ECRL's 4 — turns its curve upward.</a:t>
+              <a:t>16 per quad-rail column against ECRL's 4, and two 25 fF nodes swung per operation against one.</a:t>
             </a:r>
           </a:p>
         </p:txBody>
@@ -16202,7 +16202,7 @@
                 </a:solidFill>
                 <a:latin typeface="Calibri"/>
               </a:rPr>
-              <a:t>There is no headline “2LAL beats ECRL” result here, and we are not going to manufacture one.</a:t>
+              <a:t>Fully adiabatic beats quasi-adiabatic on energy, by a margin that grows as the clock slows.</a:t>
             </a:r>
           </a:p>
         </p:txBody>
@@ -16736,7 +16736,7 @@
                           </a:solidFill>
                           <a:latin typeface="Calibri"/>
                         </a:rPr>
-                        <a:t>44.05</a:t>
+                        <a:t>0.93</a:t>
                       </a:r>
                     </a:p>
                   </a:txBody>
@@ -16755,11 +16755,11 @@
                       <a:r>
                         <a:rPr sz="1300" b="1">
                           <a:solidFill>
-                            <a:srgbClr val="A4237A"/>
+                            <a:srgbClr val="12866B"/>
                           </a:solidFill>
                           <a:latin typeface="Calibri"/>
                         </a:rPr>
-                        <a:t>ECRL by 3.5×</a:t>
+                        <a:t>2LAL by 13.4×</a:t>
                       </a:r>
                     </a:p>
                   </a:txBody>
@@ -16876,7 +16876,7 @@
                           </a:solidFill>
                           <a:latin typeface="Calibri"/>
                         </a:rPr>
-                        <a:t>45.11</a:t>
+                        <a:t>1.44</a:t>
                       </a:r>
                     </a:p>
                   </a:txBody>
@@ -16895,11 +16895,11 @@
                       <a:r>
                         <a:rPr sz="1300" b="1">
                           <a:solidFill>
-                            <a:srgbClr val="A4237A"/>
+                            <a:srgbClr val="12866B"/>
                           </a:solidFill>
                           <a:latin typeface="Calibri"/>
                         </a:rPr>
-                        <a:t>ECRL by 3.1×</a:t>
+                        <a:t>2LAL by 10.0×</a:t>
                       </a:r>
                     </a:p>
                   </a:txBody>
@@ -17016,7 +17016,7 @@
                           </a:solidFill>
                           <a:latin typeface="Calibri"/>
                         </a:rPr>
-                        <a:t>23.97</a:t>
+                        <a:t>3.27</a:t>
                       </a:r>
                     </a:p>
                   </a:txBody>
@@ -17035,11 +17035,11 @@
                       <a:r>
                         <a:rPr sz="1300" b="1">
                           <a:solidFill>
-                            <a:srgbClr val="A4237A"/>
+                            <a:srgbClr val="12866B"/>
                           </a:solidFill>
                           <a:latin typeface="Calibri"/>
                         </a:rPr>
-                        <a:t>ECRL by 1.34×</a:t>
+                        <a:t>2LAL by 5.5×</a:t>
                       </a:r>
                     </a:p>
                   </a:txBody>
@@ -17156,7 +17156,7 @@
                           </a:solidFill>
                           <a:latin typeface="Calibri"/>
                         </a:rPr>
-                        <a:t>21.62</a:t>
+                        <a:t>6.29</a:t>
                       </a:r>
                     </a:p>
                   </a:txBody>
@@ -17175,11 +17175,11 @@
                       <a:r>
                         <a:rPr sz="1300" b="1">
                           <a:solidFill>
-                            <a:srgbClr val="768295"/>
+                            <a:srgbClr val="12866B"/>
                           </a:solidFill>
                           <a:latin typeface="Calibri"/>
                         </a:rPr>
-                        <a:t>tie</a:t>
+                        <a:t>2LAL by 3.4×</a:t>
                       </a:r>
                     </a:p>
                   </a:txBody>
@@ -17296,7 +17296,7 @@
                           </a:solidFill>
                           <a:latin typeface="Calibri"/>
                         </a:rPr>
-                        <a:t>23.87</a:t>
+                        <a:t>11.93</a:t>
                       </a:r>
                     </a:p>
                   </a:txBody>
@@ -17319,7 +17319,7 @@
                           </a:solidFill>
                           <a:latin typeface="Calibri"/>
                         </a:rPr>
-                        <a:t>2LAL by 13%</a:t>
+                        <a:t>2LAL by 2.3×</a:t>
                       </a:r>
                     </a:p>
                   </a:txBody>
@@ -17436,7 +17436,7 @@
                           </a:solidFill>
                           <a:latin typeface="Calibri"/>
                         </a:rPr>
-                        <a:t>36.86</a:t>
+                        <a:t>26.49</a:t>
                       </a:r>
                     </a:p>
                   </a:txBody>
@@ -17459,7 +17459,7 @@
                           </a:solidFill>
                           <a:latin typeface="Calibri"/>
                         </a:rPr>
-                        <a:t>2LAL by 7%</a:t>
+                        <a:t>2LAL by 1.50×</a:t>
                       </a:r>
                     </a:p>
                   </a:txBody>
@@ -17576,7 +17576,7 @@
                           </a:solidFill>
                           <a:latin typeface="Calibri"/>
                         </a:rPr>
-                        <a:t>64.95</a:t>
+                        <a:t>46.10</a:t>
                       </a:r>
                     </a:p>
                   </a:txBody>
@@ -17595,11 +17595,11 @@
                       <a:r>
                         <a:rPr sz="1300" b="1">
                           <a:solidFill>
-                            <a:srgbClr val="A4237A"/>
+                            <a:srgbClr val="12866B"/>
                           </a:solidFill>
                           <a:latin typeface="Calibri"/>
                         </a:rPr>
-                        <a:t>ECRL by 1.19×</a:t>
+                        <a:t>2LAL by 1.19×</a:t>
                       </a:r>
                     </a:p>
                   </a:txBody>
@@ -17675,7 +17675,7 @@
             <a:avLst/>
           </a:prstGeom>
           <a:solidFill>
-            <a:srgbClr val="A4237A"/>
+            <a:srgbClr val="12866B"/>
           </a:solidFill>
           <a:ln>
             <a:noFill/>
@@ -17734,7 +17734,7 @@
             <a:r>
               <a:rPr sz="1350" b="1" i="0">
                 <a:solidFill>
-                  <a:srgbClr val="A4237A"/>
+                  <a:srgbClr val="12866B"/>
                 </a:solidFill>
                 <a:latin typeface="Calibri"/>
               </a:rPr>
@@ -17757,7 +17757,7 @@
                 </a:solidFill>
                 <a:latin typeface="Calibri"/>
               </a:rPr>
-              <a:t>Both families are within a factor of two of each other across four fifths of the range. The crossover is a genuine crossing, not a gap — and it sits at a frequency where neither design is obviously the one you would reach for.</a:t>
+              <a:t>2LAL is ahead at every point, and the margin grows steadily as the clock slows. There is no crossover inside 1–1000 MHz; if one exists it lies above 1 GHz, where both are RC-limited.</a:t>
             </a:r>
           </a:p>
         </p:txBody>
@@ -17905,7 +17905,7 @@
                 </a:solidFill>
                 <a:latin typeface="Calibri"/>
               </a:rPr>
-              <a:t>Switched capacitance per operation is equal, which is what makes the energy comparison legitimate. Standing capacitance, area and leakage are not: 16 FETs and 4 loaded nodes against 4 FETs and 2.</a:t>
+              <a:t>The comparison is not capacitance-matched in 2LAL's favour: each 2LAL operation swings two 25 fF nodes (T and C) against one for ECRL, with 16 FETs against 4. 2LAL is ahead despite that.</a:t>
             </a:r>
           </a:p>
         </p:txBody>
@@ -18209,7 +18209,7 @@
                 </a:solidFill>
                 <a:latin typeface="Calibri"/>
               </a:rPr>
-              <a:t>2.16179e-14 J appears identically in the run log, in the CSV row 1.0,10,…, in the .dat file handed to gnuplot, and as the plotted point. Three independent greps, one number.</a:t>
+              <a:t>6.28912e-15 J appears identically in the run log, in the CSV row 1.0,10,…, in the .dat file handed to gnuplot, and as the plotted point. Three independent greps, one number.</a:t>
             </a:r>
           </a:p>
           <a:p>
@@ -18456,7 +18456,7 @@
                 </a:solidFill>
                 <a:latin typeface="Calibri"/>
               </a:rPr>
-              <a:t>A femtojoule / attojoule unit slip that had produced a spurious ~1000× claim in favour of 2LAL, and a “625,000×” that should have read 625×. Both corrected before anything was plotted.</a:t>
+              <a:t>A fJ/aJ unit slip (a spurious ~1000× for 2LAL), a “625,000×” that should have read 625×, and an open 2LAL chain whose unrestored end inflated its energy up to 47× — fixed by closing it into a ring.</a:t>
             </a:r>
           </a:p>
         </p:txBody>
@@ -19850,7 +19850,7 @@
                 </a:solidFill>
                 <a:latin typeface="Calibri"/>
               </a:rPr>
-              <a:t>Separate the leakage floor from the switching term</a:t>
+              <a:t>Separate leakage from the switching term</a:t>
             </a:r>
           </a:p>
         </p:txBody>
@@ -19889,7 +19889,7 @@
                 </a:solidFill>
                 <a:latin typeface="Calibri"/>
               </a:rPr>
-              <a:t>Measure at zero activity and subtract, so the RC/T term can be isolated. That would explain the 2LAL upturn quantitatively instead of by inference.</a:t>
+              <a:t>Measure at zero activity and subtract, so the RC/T term can be isolated. That would pin down where extra width stops helping 2LAL at slow clocks.</a:t>
             </a:r>
           </a:p>
         </p:txBody>
@@ -21918,7 +21918,7 @@
                 </a:solidFill>
                 <a:latin typeface="Calibri"/>
               </a:rPr>
-              <a:t>ECRL below 100 MHz, a tie at 100 MHz, 2LAL by 7–13% in a narrow 200–500 MHz band</a:t>
+              <a:t>2LAL lower at every frequency: 1.19× at 1000 MHz, 13.4× at 10 MHz</a:t>
             </a:r>
           </a:p>
         </p:txBody>
@@ -23692,7 +23692,7 @@
                 </a:solidFill>
                 <a:latin typeface="Calibri"/>
               </a:rPr>
-              <a:t>2LAL quad-rail inverter</a:t>
+              <a:t>2LAL quad-rail inverter (8-stage ring)</a:t>
             </a:r>
           </a:p>
         </p:txBody>
@@ -23924,7 +23924,7 @@
                           </a:solidFill>
                           <a:latin typeface="Calibri"/>
                         </a:rPr>
-                        <a:t>43.38</a:t>
+                        <a:t>1.27</a:t>
                       </a:r>
                     </a:p>
                   </a:txBody>
@@ -23947,7 +23947,7 @@
                           </a:solidFill>
                           <a:latin typeface="Calibri"/>
                         </a:rPr>
-                        <a:t>44.05</a:t>
+                        <a:t>0.93</a:t>
                       </a:r>
                     </a:p>
                   </a:txBody>
@@ -23970,7 +23970,7 @@
                           </a:solidFill>
                           <a:latin typeface="Calibri"/>
                         </a:rPr>
-                        <a:t>44.65</a:t>
+                        <a:t>0.67</a:t>
                       </a:r>
                     </a:p>
                   </a:txBody>
@@ -23993,7 +23993,7 @@
                           </a:solidFill>
                           <a:latin typeface="Calibri"/>
                         </a:rPr>
-                        <a:t>46.04</a:t>
+                        <a:t>0.62</a:t>
                       </a:r>
                     </a:p>
                   </a:txBody>
@@ -24016,7 +24016,7 @@
                           </a:solidFill>
                           <a:latin typeface="Calibri"/>
                         </a:rPr>
-                        <a:t>49.20</a:t>
+                        <a:t>0.75</a:t>
                       </a:r>
                     </a:p>
                   </a:txBody>
@@ -24039,7 +24039,7 @@
                           </a:solidFill>
                           <a:latin typeface="Calibri"/>
                         </a:rPr>
-                        <a:t>56.09</a:t>
+                        <a:t>0.90</a:t>
                       </a:r>
                     </a:p>
                   </a:txBody>
@@ -24087,7 +24087,7 @@
                           </a:solidFill>
                           <a:latin typeface="Calibri"/>
                         </a:rPr>
-                        <a:t>42.53</a:t>
+                        <a:t>1.70</a:t>
                       </a:r>
                     </a:p>
                   </a:txBody>
@@ -24110,7 +24110,7 @@
                           </a:solidFill>
                           <a:latin typeface="Calibri"/>
                         </a:rPr>
-                        <a:t>45.11</a:t>
+                        <a:t>1.44</a:t>
                       </a:r>
                     </a:p>
                   </a:txBody>
@@ -24133,7 +24133,7 @@
                           </a:solidFill>
                           <a:latin typeface="Calibri"/>
                         </a:rPr>
-                        <a:t>46.63</a:t>
+                        <a:t>1.22</a:t>
                       </a:r>
                     </a:p>
                   </a:txBody>
@@ -24156,7 +24156,7 @@
                           </a:solidFill>
                           <a:latin typeface="Calibri"/>
                         </a:rPr>
-                        <a:t>47.62</a:t>
+                        <a:t>1.06</a:t>
                       </a:r>
                     </a:p>
                   </a:txBody>
@@ -24179,7 +24179,7 @@
                           </a:solidFill>
                           <a:latin typeface="Calibri"/>
                         </a:rPr>
-                        <a:t>50.53</a:t>
+                        <a:t>1.06</a:t>
                       </a:r>
                     </a:p>
                   </a:txBody>
@@ -24202,7 +24202,7 @@
                           </a:solidFill>
                           <a:latin typeface="Calibri"/>
                         </a:rPr>
-                        <a:t>57.10</a:t>
+                        <a:t>1.08</a:t>
                       </a:r>
                     </a:p>
                   </a:txBody>
@@ -24250,7 +24250,7 @@
                           </a:solidFill>
                           <a:latin typeface="Calibri"/>
                         </a:rPr>
-                        <a:t>21.29</a:t>
+                        <a:t>3.61</a:t>
                       </a:r>
                     </a:p>
                   </a:txBody>
@@ -24273,7 +24273,7 @@
                           </a:solidFill>
                           <a:latin typeface="Calibri"/>
                         </a:rPr>
-                        <a:t>23.97</a:t>
+                        <a:t>3.27</a:t>
                       </a:r>
                     </a:p>
                   </a:txBody>
@@ -24296,7 +24296,7 @@
                           </a:solidFill>
                           <a:latin typeface="Calibri"/>
                         </a:rPr>
-                        <a:t>32.05</a:t>
+                        <a:t>2.94</a:t>
                       </a:r>
                     </a:p>
                   </a:txBody>
@@ -24319,7 +24319,7 @@
                           </a:solidFill>
                           <a:latin typeface="Calibri"/>
                         </a:rPr>
-                        <a:t>49.92</a:t>
+                        <a:t>2.50</a:t>
                       </a:r>
                     </a:p>
                   </a:txBody>
@@ -24342,7 +24342,7 @@
                           </a:solidFill>
                           <a:latin typeface="Calibri"/>
                         </a:rPr>
-                        <a:t>54.15</a:t>
+                        <a:t>2.34</a:t>
                       </a:r>
                     </a:p>
                   </a:txBody>
@@ -24365,7 +24365,7 @@
                           </a:solidFill>
                           <a:latin typeface="Calibri"/>
                         </a:rPr>
-                        <a:t>60.16</a:t>
+                        <a:t>2.18</a:t>
                       </a:r>
                     </a:p>
                   </a:txBody>
@@ -24413,7 +24413,7 @@
                           </a:solidFill>
                           <a:latin typeface="Calibri"/>
                         </a:rPr>
-                        <a:t>20.40</a:t>
+                        <a:t>6.88</a:t>
                       </a:r>
                     </a:p>
                   </a:txBody>
@@ -24436,7 +24436,7 @@
                           </a:solidFill>
                           <a:latin typeface="Calibri"/>
                         </a:rPr>
-                        <a:t>21.62</a:t>
+                        <a:t>6.29</a:t>
                       </a:r>
                     </a:p>
                   </a:txBody>
@@ -24459,7 +24459,7 @@
                           </a:solidFill>
                           <a:latin typeface="Calibri"/>
                         </a:rPr>
-                        <a:t>23.83</a:t>
+                        <a:t>5.73</a:t>
                       </a:r>
                     </a:p>
                   </a:txBody>
@@ -24482,7 +24482,7 @@
                           </a:solidFill>
                           <a:latin typeface="Calibri"/>
                         </a:rPr>
-                        <a:t>30.61</a:t>
+                        <a:t>4.89</a:t>
                       </a:r>
                     </a:p>
                   </a:txBody>
@@ -24505,7 +24505,7 @@
                           </a:solidFill>
                           <a:latin typeface="Calibri"/>
                         </a:rPr>
-                        <a:t>54.03</a:t>
+                        <a:t>4.53</a:t>
                       </a:r>
                     </a:p>
                   </a:txBody>
@@ -24528,7 +24528,7 @@
                           </a:solidFill>
                           <a:latin typeface="Calibri"/>
                         </a:rPr>
-                        <a:t>64.20</a:t>
+                        <a:t>4.17</a:t>
                       </a:r>
                     </a:p>
                   </a:txBody>
@@ -24576,7 +24576,7 @@
                           </a:solidFill>
                           <a:latin typeface="Calibri"/>
                         </a:rPr>
-                        <a:t>23.71</a:t>
+                        <a:t>13.01</a:t>
                       </a:r>
                     </a:p>
                   </a:txBody>
@@ -24599,7 +24599,7 @@
                           </a:solidFill>
                           <a:latin typeface="Calibri"/>
                         </a:rPr>
-                        <a:t>23.87</a:t>
+                        <a:t>11.93</a:t>
                       </a:r>
                     </a:p>
                   </a:txBody>
@@ -24622,7 +24622,7 @@
                           </a:solidFill>
                           <a:latin typeface="Calibri"/>
                         </a:rPr>
-                        <a:t>24.38</a:t>
+                        <a:t>10.96</a:t>
                       </a:r>
                     </a:p>
                   </a:txBody>
@@ -24645,7 +24645,7 @@
                           </a:solidFill>
                           <a:latin typeface="Calibri"/>
                         </a:rPr>
-                        <a:t>26.95</a:t>
+                        <a:t>9.44</a:t>
                       </a:r>
                     </a:p>
                   </a:txBody>
@@ -24668,7 +24668,7 @@
                           </a:solidFill>
                           <a:latin typeface="Calibri"/>
                         </a:rPr>
-                        <a:t>32.76</a:t>
+                        <a:t>8.75</a:t>
                       </a:r>
                     </a:p>
                   </a:txBody>
@@ -24691,7 +24691,7 @@
                           </a:solidFill>
                           <a:latin typeface="Calibri"/>
                         </a:rPr>
-                        <a:t>61.47</a:t>
+                        <a:t>8.06</a:t>
                       </a:r>
                     </a:p>
                   </a:txBody>
@@ -24739,7 +24739,7 @@
                           </a:solidFill>
                           <a:latin typeface="Calibri"/>
                         </a:rPr>
-                        <a:t>36.81</a:t>
+                        <a:t>28.81</a:t>
                       </a:r>
                     </a:p>
                   </a:txBody>
@@ -24762,7 +24762,7 @@
                           </a:solidFill>
                           <a:latin typeface="Calibri"/>
                         </a:rPr>
-                        <a:t>36.86</a:t>
+                        <a:t>26.49</a:t>
                       </a:r>
                     </a:p>
                   </a:txBody>
@@ -24785,7 +24785,7 @@
                           </a:solidFill>
                           <a:latin typeface="Calibri"/>
                         </a:rPr>
-                        <a:t>40.73</a:t>
+                        <a:t>24.59</a:t>
                       </a:r>
                     </a:p>
                   </a:txBody>
@@ -24808,7 +24808,7 @@
                           </a:solidFill>
                           <a:latin typeface="Calibri"/>
                         </a:rPr>
-                        <a:t>34.87</a:t>
+                        <a:t>21.59</a:t>
                       </a:r>
                     </a:p>
                   </a:txBody>
@@ -24831,7 +24831,7 @@
                           </a:solidFill>
                           <a:latin typeface="Calibri"/>
                         </a:rPr>
-                        <a:t>38.45</a:t>
+                        <a:t>20.06</a:t>
                       </a:r>
                     </a:p>
                   </a:txBody>
@@ -24854,7 +24854,7 @@
                           </a:solidFill>
                           <a:latin typeface="Calibri"/>
                         </a:rPr>
-                        <a:t>42.11</a:t>
+                        <a:t>18.70</a:t>
                       </a:r>
                     </a:p>
                   </a:txBody>
@@ -24902,7 +24902,7 @@
                           </a:solidFill>
                           <a:latin typeface="Calibri"/>
                         </a:rPr>
-                        <a:t>61.70</a:t>
+                        <a:t>50.30</a:t>
                       </a:r>
                     </a:p>
                   </a:txBody>
@@ -24925,7 +24925,7 @@
                           </a:solidFill>
                           <a:latin typeface="Calibri"/>
                         </a:rPr>
-                        <a:t>64.95</a:t>
+                        <a:t>46.10</a:t>
                       </a:r>
                     </a:p>
                   </a:txBody>
@@ -24948,7 +24948,7 @@
                           </a:solidFill>
                           <a:latin typeface="Calibri"/>
                         </a:rPr>
-                        <a:t>70.74</a:t>
+                        <a:t>43.05</a:t>
                       </a:r>
                     </a:p>
                   </a:txBody>
@@ -24971,7 +24971,7 @@
                           </a:solidFill>
                           <a:latin typeface="Calibri"/>
                         </a:rPr>
-                        <a:t>68.63</a:t>
+                        <a:t>38.42</a:t>
                       </a:r>
                     </a:p>
                   </a:txBody>
@@ -24994,7 +24994,7 @@
                           </a:solidFill>
                           <a:latin typeface="Calibri"/>
                         </a:rPr>
-                        <a:t>71.14</a:t>
+                        <a:t>35.91</a:t>
                       </a:r>
                     </a:p>
                   </a:txBody>
@@ -25017,7 +25017,7 @@
                           </a:solidFill>
                           <a:latin typeface="Calibri"/>
                         </a:rPr>
-                        <a:t>76.84</a:t>
+                        <a:t>33.95</a:t>
                       </a:r>
                     </a:p>
                   </a:txBody>
@@ -25066,7 +25066,7 @@
                 </a:solidFill>
                 <a:latin typeface="Calibri"/>
               </a:rPr>
-              <a:t>Note the difference in the width trend. ECRL improves with width at high frequency and is flat at low frequency. 2LAL gets worse with width at every frequency measured — its pass gates are not resistance-limited in this range, so extra width buys nothing and costs capacitance and leakage.</a:t>
+              <a:t>Note the width trend. ECRL improves with width at high frequency and is nearly flat at low frequency. 2LAL improves with width at every frequency down to 50 MHz; at 20 and 10 MHz it bottoms out near W = 1.5 µm and the widest devices cost more again.</a:t>
             </a:r>
           </a:p>
           <a:p>

</xml_diff>